<commit_message>
Refit anatomy fixtures and clarify judge demo scope
</commit_message>
<xml_diff>
--- a/src/web_demo/fixtures/assets/servier-visual-ar.pptx
+++ b/src/web_demo/fixtures/assets/servier-visual-ar.pptx
@@ -3133,53 +3133,6 @@
           <a:chExt cx="0" cy="0"/>
         </a:xfrm>
       </p:grpSpPr>
-      <p:pic>
-        <p:nvPicPr>
-          <p:cNvPr id="7" name="Picture 2">
-            <a:extLst>
-              <a:ext uri="{FF2B5EF4-FFF2-40B4-BE49-F238E27FC236}">
-                <a16:creationId xmlns:a16="http://schemas.microsoft.com/office/drawing/2014/main" id="{FB140520-6CC9-8398-5BBC-338790D77AF9}"/>
-              </a:ext>
-            </a:extLst>
-          </p:cNvPr>
-          <p:cNvPicPr>
-            <a:picLocks noChangeAspect="1" noChangeArrowheads="1"/>
-          </p:cNvPicPr>
-          <p:nvPr userDrawn="1"/>
-        </p:nvPicPr>
-        <p:blipFill>
-          <a:blip r:embed="rId13">
-            <a:extLst>
-              <a:ext uri="{28A0092B-C50C-407E-A947-70E740481C1C}">
-                <a14:useLocalDpi xmlns:a14="http://schemas.microsoft.com/office/drawing/2010/main" val="0"/>
-              </a:ext>
-            </a:extLst>
-          </a:blip>
-          <a:srcRect/>
-          <a:stretch>
-            <a:fillRect/>
-          </a:stretch>
-        </p:blipFill>
-        <p:spPr bwMode="auto">
-          <a:xfrm>
-            <a:off x="7695719" y="6018062"/>
-            <a:ext cx="1397947" cy="466468"/>
-          </a:xfrm>
-          <a:prstGeom prst="rect">
-            <a:avLst/>
-          </a:prstGeom>
-          <a:noFill/>
-          <a:extLst>
-            <a:ext uri="{909E8E84-426E-40DD-AFC4-6F175D3DCCD1}">
-              <a14:hiddenFill xmlns:a14="http://schemas.microsoft.com/office/drawing/2010/main">
-                <a:solidFill>
-                  <a:srgbClr val="FFFFFF"/>
-                </a:solidFill>
-              </a14:hiddenFill>
-            </a:ext>
-          </a:extLst>
-        </p:spPr>
-      </p:pic>
       <p:sp>
         <p:nvSpPr>
           <p:cNvPr id="8" name="ZoneTexte 7">
@@ -3220,7 +3173,7 @@
                 <a:latin typeface="Poppins" panose="00000500000000000000" pitchFamily="2" charset="0"/>
                 <a:cs typeface="Poppins" panose="00000500000000000000" pitchFamily="2" charset="0"/>
               </a:rPr>
-              <a:t>All SMART images are </a:t>
+              <a:t>Servier Medical Art illustration adapted (CC BY 4.0). https://creativecommons.org/licenses/by/4.0/</a:t>
             </a:r>
             <a:r>
               <a:rPr lang="fr-FR" sz="700" dirty="0" err="1">
@@ -3233,7 +3186,7 @@
                 <a:latin typeface="Poppins" panose="00000500000000000000" pitchFamily="2" charset="0"/>
                 <a:cs typeface="Poppins" panose="00000500000000000000" pitchFamily="2" charset="0"/>
               </a:rPr>
-              <a:t>licensed</a:t>
+              <a:t/>
             </a:r>
             <a:r>
               <a:rPr lang="fr-FR" sz="700" dirty="0">
@@ -3246,7 +3199,7 @@
                 <a:latin typeface="Poppins" panose="00000500000000000000" pitchFamily="2" charset="0"/>
                 <a:cs typeface="Poppins" panose="00000500000000000000" pitchFamily="2" charset="0"/>
               </a:rPr>
-              <a:t> </a:t>
+              <a:t/>
             </a:r>
             <a:r>
               <a:rPr lang="fr-FR" sz="700" dirty="0" err="1">
@@ -3259,7 +3212,7 @@
                 <a:latin typeface="Poppins" panose="00000500000000000000" pitchFamily="2" charset="0"/>
                 <a:cs typeface="Poppins" panose="00000500000000000000" pitchFamily="2" charset="0"/>
               </a:rPr>
-              <a:t>under</a:t>
+              <a:t/>
             </a:r>
             <a:r>
               <a:rPr lang="fr-FR" sz="700" dirty="0">
@@ -3272,7 +3225,7 @@
                 <a:latin typeface="Poppins" panose="00000500000000000000" pitchFamily="2" charset="0"/>
                 <a:cs typeface="Poppins" panose="00000500000000000000" pitchFamily="2" charset="0"/>
               </a:rPr>
-              <a:t> Creative Commons Attribution 4.0 </a:t>
+              <a:t/>
             </a:r>
           </a:p>
           <a:p>
@@ -3288,7 +3241,7 @@
                 <a:latin typeface="Poppins" panose="00000500000000000000" pitchFamily="2" charset="0"/>
                 <a:cs typeface="Poppins" panose="00000500000000000000" pitchFamily="2" charset="0"/>
               </a:rPr>
-              <a:t>Share, </a:t>
+              <a:t/>
             </a:r>
             <a:r>
               <a:rPr lang="fr-FR" sz="700" dirty="0" err="1">
@@ -3301,7 +3254,7 @@
                 <a:latin typeface="Poppins" panose="00000500000000000000" pitchFamily="2" charset="0"/>
                 <a:cs typeface="Poppins" panose="00000500000000000000" pitchFamily="2" charset="0"/>
               </a:rPr>
-              <a:t>adapt</a:t>
+              <a:t/>
             </a:r>
             <a:r>
               <a:rPr lang="fr-FR" sz="700" dirty="0">
@@ -3314,7 +3267,7 @@
                 <a:latin typeface="Poppins" panose="00000500000000000000" pitchFamily="2" charset="0"/>
                 <a:cs typeface="Poppins" panose="00000500000000000000" pitchFamily="2" charset="0"/>
               </a:rPr>
-              <a:t>, and </a:t>
+              <a:t/>
             </a:r>
             <a:r>
               <a:rPr lang="fr-FR" sz="700" dirty="0" err="1">
@@ -3327,7 +3280,7 @@
                 <a:latin typeface="Poppins" panose="00000500000000000000" pitchFamily="2" charset="0"/>
                 <a:cs typeface="Poppins" panose="00000500000000000000" pitchFamily="2" charset="0"/>
               </a:rPr>
-              <a:t>enhance</a:t>
+              <a:t/>
             </a:r>
             <a:r>
               <a:rPr lang="fr-FR" sz="700" dirty="0">
@@ -3340,7 +3293,7 @@
                 <a:latin typeface="Poppins" panose="00000500000000000000" pitchFamily="2" charset="0"/>
                 <a:cs typeface="Poppins" panose="00000500000000000000" pitchFamily="2" charset="0"/>
               </a:rPr>
-              <a:t> </a:t>
+              <a:t/>
             </a:r>
             <a:r>
               <a:rPr lang="fr-FR" sz="700" dirty="0" err="1">
@@ -3353,7 +3306,7 @@
                 <a:latin typeface="Poppins" panose="00000500000000000000" pitchFamily="2" charset="0"/>
                 <a:cs typeface="Poppins" panose="00000500000000000000" pitchFamily="2" charset="0"/>
               </a:rPr>
-              <a:t>your</a:t>
+              <a:t/>
             </a:r>
             <a:r>
               <a:rPr lang="fr-FR" sz="700" dirty="0">
@@ -3366,7 +3319,7 @@
                 <a:latin typeface="Poppins" panose="00000500000000000000" pitchFamily="2" charset="0"/>
                 <a:cs typeface="Poppins" panose="00000500000000000000" pitchFamily="2" charset="0"/>
               </a:rPr>
-              <a:t> </a:t>
+              <a:t/>
             </a:r>
             <a:r>
               <a:rPr lang="fr-FR" sz="700" dirty="0" err="1">
@@ -3379,7 +3332,7 @@
                 <a:latin typeface="Poppins" panose="00000500000000000000" pitchFamily="2" charset="0"/>
                 <a:cs typeface="Poppins" panose="00000500000000000000" pitchFamily="2" charset="0"/>
               </a:rPr>
-              <a:t>presentations</a:t>
+              <a:t/>
             </a:r>
             <a:r>
               <a:rPr lang="fr-FR" sz="700" dirty="0">
@@ -3392,7 +3345,7 @@
                 <a:latin typeface="Poppins" panose="00000500000000000000" pitchFamily="2" charset="0"/>
                 <a:cs typeface="Poppins" panose="00000500000000000000" pitchFamily="2" charset="0"/>
               </a:rPr>
-              <a:t> </a:t>
+              <a:t/>
             </a:r>
             <a:r>
               <a:rPr lang="fr-FR" sz="700" dirty="0" err="1">
@@ -3405,7 +3358,7 @@
                 <a:latin typeface="Poppins" panose="00000500000000000000" pitchFamily="2" charset="0"/>
                 <a:cs typeface="Poppins" panose="00000500000000000000" pitchFamily="2" charset="0"/>
               </a:rPr>
-              <a:t>with</a:t>
+              <a:t/>
             </a:r>
             <a:r>
               <a:rPr lang="fr-FR" sz="700" dirty="0">
@@ -3418,7 +3371,7 @@
                 <a:latin typeface="Poppins" panose="00000500000000000000" pitchFamily="2" charset="0"/>
                 <a:cs typeface="Poppins" panose="00000500000000000000" pitchFamily="2" charset="0"/>
               </a:rPr>
-              <a:t> the power of open collaboration. </a:t>
+              <a:t/>
             </a:r>
             <a:r>
               <a:rPr lang="fr-FR" sz="700" dirty="0">
@@ -3438,7 +3391,7 @@
                   </a:extLst>
                 </a:hlinkClick>
               </a:rPr>
-              <a:t>https://creativecommons.org/licenses/by/4.0/</a:t>
+              <a:t/>
             </a:r>
             <a:endParaRPr lang="fr-FR" sz="700" dirty="0">
               <a:solidFill>
@@ -3453,117 +3406,6 @@
           </a:p>
         </p:txBody>
       </p:sp>
-      <p:sp>
-        <p:nvSpPr>
-          <p:cNvPr id="9" name="ZoneTexte 8">
-            <a:extLst>
-              <a:ext uri="{FF2B5EF4-FFF2-40B4-BE49-F238E27FC236}">
-                <a16:creationId xmlns:a16="http://schemas.microsoft.com/office/drawing/2014/main" id="{49C18B3B-3B5B-F650-4348-B2A33155E287}"/>
-              </a:ext>
-            </a:extLst>
-          </p:cNvPr>
-          <p:cNvSpPr txBox="1"/>
-          <p:nvPr userDrawn="1"/>
-        </p:nvSpPr>
-        <p:spPr>
-          <a:xfrm>
-            <a:off x="5629013" y="6133850"/>
-            <a:ext cx="2204450" cy="369332"/>
-          </a:xfrm>
-          <a:prstGeom prst="rect">
-            <a:avLst/>
-          </a:prstGeom>
-          <a:noFill/>
-        </p:spPr>
-        <p:txBody>
-          <a:bodyPr wrap="none" rtlCol="0">
-            <a:spAutoFit/>
-          </a:bodyPr>
-          <a:lstStyle/>
-          <a:p>
-            <a:r>
-              <a:rPr lang="fr-FR" i="1" dirty="0" err="1">
-                <a:solidFill>
-                  <a:srgbClr val="24226A"/>
-                </a:solidFill>
-                <a:latin typeface="Poppins" panose="00000500000000000000" pitchFamily="2" charset="0"/>
-                <a:cs typeface="Poppins" panose="00000500000000000000" pitchFamily="2" charset="0"/>
-              </a:rPr>
-              <a:t>Educational</a:t>
-            </a:r>
-            <a:r>
-              <a:rPr lang="fr-FR" i="1" dirty="0">
-                <a:solidFill>
-                  <a:srgbClr val="24226A"/>
-                </a:solidFill>
-                <a:latin typeface="Poppins" panose="00000500000000000000" pitchFamily="2" charset="0"/>
-                <a:cs typeface="Poppins" panose="00000500000000000000" pitchFamily="2" charset="0"/>
-              </a:rPr>
-              <a:t> Tools</a:t>
-            </a:r>
-          </a:p>
-        </p:txBody>
-      </p:sp>
-      <p:pic>
-        <p:nvPicPr>
-          <p:cNvPr id="10" name="Image 9">
-            <a:extLst>
-              <a:ext uri="{FF2B5EF4-FFF2-40B4-BE49-F238E27FC236}">
-                <a16:creationId xmlns:a16="http://schemas.microsoft.com/office/drawing/2014/main" id="{5429A786-9DA0-29B4-DDC0-97337C848C95}"/>
-              </a:ext>
-            </a:extLst>
-          </p:cNvPr>
-          <p:cNvPicPr>
-            <a:picLocks noChangeAspect="1"/>
-          </p:cNvPicPr>
-          <p:nvPr userDrawn="1"/>
-        </p:nvPicPr>
-        <p:blipFill>
-          <a:blip r:embed="rId15">
-            <a:extLst>
-              <a:ext uri="{28A0092B-C50C-407E-A947-70E740481C1C}">
-                <a14:useLocalDpi xmlns:a14="http://schemas.microsoft.com/office/drawing/2010/main" val="0"/>
-              </a:ext>
-            </a:extLst>
-          </a:blip>
-          <a:srcRect/>
-          <a:stretch>
-            <a:fillRect/>
-          </a:stretch>
-        </p:blipFill>
-        <p:spPr bwMode="auto">
-          <a:xfrm>
-            <a:off x="8067195" y="96116"/>
-            <a:ext cx="862064" cy="735779"/>
-          </a:xfrm>
-          <a:prstGeom prst="rect">
-            <a:avLst/>
-          </a:prstGeom>
-          <a:noFill/>
-          <a:ln>
-            <a:noFill/>
-          </a:ln>
-          <a:extLst>
-            <a:ext uri="{909E8E84-426E-40DD-AFC4-6F175D3DCCD1}">
-              <a14:hiddenFill xmlns:a14="http://schemas.microsoft.com/office/drawing/2010/main">
-                <a:solidFill>
-                  <a:srgbClr val="FFFFFF"/>
-                </a:solidFill>
-              </a14:hiddenFill>
-            </a:ext>
-            <a:ext uri="{91240B29-F687-4F45-9708-019B960494DF}">
-              <a14:hiddenLine xmlns:a14="http://schemas.microsoft.com/office/drawing/2010/main" w="9525">
-                <a:solidFill>
-                  <a:srgbClr val="000000"/>
-                </a:solidFill>
-                <a:miter lim="800000"/>
-                <a:headEnd/>
-                <a:tailEnd/>
-              </a14:hiddenLine>
-            </a:ext>
-          </a:extLst>
-        </p:spPr>
-      </p:pic>
     </p:spTree>
     <p:extLst>
       <p:ext uri="{BB962C8B-B14F-4D97-AF65-F5344CB8AC3E}">
@@ -3951,8 +3793,8 @@
         </p:nvSpPr>
         <p:spPr>
           <a:xfrm>
-            <a:off x="0" y="0"/>
-            <a:ext cx="9144000" cy="830997"/>
+            <a:off x="0" y="76200"/>
+            <a:ext cx="9144000" cy="754797"/>
           </a:xfrm>
           <a:prstGeom prst="rect">
             <a:avLst/>
@@ -3967,7 +3809,7 @@
           <a:p>
             <a:pPr algn="ctr"/>
             <a:r>
-              <a:rPr lang="ar-SA" sz="4800" b="1" dirty="0">
+              <a:rPr lang="ar-SA" sz="4400" b="1" dirty="0">
                 <a:solidFill>
                   <a:srgbClr val="9C7DCC"/>
                 </a:solidFill>
@@ -4009,7 +3851,7 @@
           <a:p>
             <a:pPr algn="ctr"/>
             <a:r>
-              <a:rPr lang="ar-SA" sz="1200" dirty="0">
+              <a:rPr lang="ar-SA" sz="1100" dirty="0">
                 <a:latin typeface="Poppins" panose="00000500000000000000" pitchFamily="2" charset="0"/>
                 <a:cs typeface="Arial" panose="00000500000000000000" pitchFamily="2" charset="0"/>
               </a:rPr>
@@ -4074,8 +3916,8 @@
         </p:nvSpPr>
         <p:spPr>
           <a:xfrm>
-            <a:off x="7008460" y="2187918"/>
-            <a:ext cx="1283516" cy="645952"/>
+            <a:off x="6817960" y="2187918"/>
+            <a:ext cx="1664516" cy="645952"/>
           </a:xfrm>
           <a:prstGeom prst="cloud">
             <a:avLst/>
@@ -4183,8 +4025,8 @@
         </p:nvSpPr>
         <p:spPr>
           <a:xfrm>
-            <a:off x="7008460" y="2833870"/>
-            <a:ext cx="1283516" cy="645952"/>
+            <a:off x="6817960" y="2833870"/>
+            <a:ext cx="1664516" cy="645952"/>
           </a:xfrm>
           <a:prstGeom prst="cloud">
             <a:avLst/>
@@ -4339,8 +4181,8 @@
         </p:nvSpPr>
         <p:spPr>
           <a:xfrm>
-            <a:off x="7008460" y="3495308"/>
-            <a:ext cx="1283516" cy="645952"/>
+            <a:off x="6817960" y="3495308"/>
+            <a:ext cx="1664516" cy="645952"/>
           </a:xfrm>
           <a:prstGeom prst="cloud">
             <a:avLst/>
@@ -4447,8 +4289,8 @@
         </p:nvSpPr>
         <p:spPr>
           <a:xfrm>
-            <a:off x="6996468" y="4196681"/>
-            <a:ext cx="1283516" cy="645952"/>
+            <a:off x="6805968" y="4196681"/>
+            <a:ext cx="1664516" cy="645952"/>
           </a:xfrm>
           <a:prstGeom prst="cloud">
             <a:avLst/>
@@ -4604,8 +4446,8 @@
         </p:nvSpPr>
         <p:spPr>
           <a:xfrm>
-            <a:off x="1144505" y="4349081"/>
-            <a:ext cx="1283516" cy="645952"/>
+            <a:off x="954005" y="4349081"/>
+            <a:ext cx="1664516" cy="645952"/>
           </a:xfrm>
           <a:prstGeom prst="cloud">
             <a:avLst/>
@@ -4760,8 +4602,8 @@
         </p:nvSpPr>
         <p:spPr>
           <a:xfrm>
-            <a:off x="1140524" y="5030745"/>
-            <a:ext cx="1283516" cy="645952"/>
+            <a:off x="950024" y="5030745"/>
+            <a:ext cx="1664516" cy="645952"/>
           </a:xfrm>
           <a:prstGeom prst="cloud">
             <a:avLst/>
@@ -4916,8 +4758,8 @@
         </p:nvSpPr>
         <p:spPr>
           <a:xfrm>
-            <a:off x="1107888" y="5733658"/>
-            <a:ext cx="1283516" cy="645952"/>
+            <a:off x="917388" y="5733658"/>
+            <a:ext cx="1664516" cy="645952"/>
           </a:xfrm>
           <a:prstGeom prst="cloud">
             <a:avLst/>
@@ -5072,8 +4914,8 @@
         </p:nvSpPr>
         <p:spPr>
           <a:xfrm>
-            <a:off x="1093385" y="3615474"/>
-            <a:ext cx="1342779" cy="700859"/>
+            <a:off x="902885" y="3615474"/>
+            <a:ext cx="1723779" cy="700859"/>
           </a:xfrm>
           <a:prstGeom prst="cloud">
             <a:avLst/>
@@ -5180,8 +5022,8 @@
         </p:nvSpPr>
         <p:spPr>
           <a:xfrm>
-            <a:off x="1140524" y="2936774"/>
-            <a:ext cx="1283516" cy="645952"/>
+            <a:off x="950024" y="2936774"/>
+            <a:ext cx="1664516" cy="645952"/>
           </a:xfrm>
           <a:prstGeom prst="cloud">
             <a:avLst/>
@@ -5336,8 +5178,8 @@
         </p:nvSpPr>
         <p:spPr>
           <a:xfrm>
-            <a:off x="1107888" y="2234391"/>
-            <a:ext cx="1329849" cy="649089"/>
+            <a:off x="917388" y="2234391"/>
+            <a:ext cx="1710849" cy="649089"/>
           </a:xfrm>
           <a:prstGeom prst="cloud">
             <a:avLst/>
@@ -5492,8 +5334,8 @@
         </p:nvSpPr>
         <p:spPr>
           <a:xfrm>
-            <a:off x="1029372" y="1536626"/>
-            <a:ext cx="1362032" cy="645952"/>
+            <a:off x="838872" y="1536626"/>
+            <a:ext cx="1743032" cy="645952"/>
           </a:xfrm>
           <a:prstGeom prst="cloud">
             <a:avLst/>
@@ -5648,8 +5490,8 @@
         </p:nvSpPr>
         <p:spPr>
           <a:xfrm>
-            <a:off x="7034727" y="1510858"/>
-            <a:ext cx="1652940" cy="645952"/>
+            <a:off x="6844227" y="1510858"/>
+            <a:ext cx="2033940" cy="645952"/>
           </a:xfrm>
           <a:prstGeom prst="cloud">
             <a:avLst/>

</xml_diff>